<commit_message>
Presentación AMMX y One Pager: cambios de Seguridad y Relaciones Laborales
- ILUO: la plataforma apoya el nivel I sin acreditarlo, sin asignar niveles
  ni ser requisito; validación con RH, Relaciones Laborales y CMCAP
- Reglas 4 y 5 con texto íntegro en el One Pager; CCT pendiente de revisar
- Portada marcada como material de práctica (DEMO)

Co-Authored-By: Claude Opus 5.5 <noreply@anthropic.com>
Claude-Session: https://claude.ai/code/session_01KNk188BQs5d5yrXcfpDDFP
</commit_message>
<xml_diff>
--- a/entregables/2026-10-08-presentacion-comite/Academia_Digital_Capacitacion_por_Misiones_AMMX.pptx
+++ b/entregables/2026-10-08-presentacion-comite/Academia_Digital_Capacitacion_por_Misiones_AMMX.pptx
@@ -1222,8 +1222,8 @@
           <a:p>
             <a:r>
               <a:rPr lang="en-US" dirty="0"/>
-              <a:t>CÓMO EXPLICARLA: Ubicar la plataforma en el modelo ILUO evita la confusión más peligrosa: creer que terminar una misión habilita para la tarea. La plataforma solo aporta al nivel I.
-PUNTOS A CERRAR: (1) Que Seguridad y RH validen esta alineación.
+              <a:t>CÓMO EXPLICARLA: Ubicar la plataforma en el modelo ILUO evita la confusión más peligrosa: creer que terminar una misión habilita para la tarea. La plataforma solo apoya el nivel I; no lo acredita.
+PUNTOS A CERRAR: (1) Que Seguridad, RH y Relaciones Laborales validen esta alineación y confirmen si la matriz ILUO se usa hoy para escalafón, categorías o bonos (verificar con Jurídico Laboral).
 [POR CONFIRMAR] Alineación con la matriz ILUO (propuesta).</a:t>
             </a:r>
             <a:endParaRPr lang="en-US" dirty="0"/>
@@ -1928,7 +1928,7 @@
                 <a:ea typeface="Century Gothic" pitchFamily="34" charset="-122"/>
                 <a:cs typeface="Century Gothic" pitchFamily="34" charset="-120"/>
               </a:rPr>
-              <a:t>ACADEMIA DIGITAL · PROPUESTA · OCTUBRE 2026</a:t>
+              <a:t>PROPUESTA · OCTUBRE 2026 · MATERIAL DE PRÁCTICA (DEMO)</a:t>
             </a:r>
             <a:endParaRPr lang="en-US" sz="1100" dirty="0"/>
           </a:p>
@@ -3942,7 +3942,7 @@
                           <a:ea typeface="Century Gothic" pitchFamily="34" charset="-122"/>
                           <a:cs typeface="Century Gothic" pitchFamily="34" charset="-120"/>
                         </a:rPr>
-                        <a:t>Aviso DEMO, guion del instructor y criterio de paro.</a:t>
+                        <a:t>Aviso DEMO, guion del instructor (si algo difiere, manda el procedimiento vigente de la planta) y criterio de paro.</a:t>
                       </a:r>
                       <a:endParaRPr lang="en-US" sz="950" dirty="0">
                         <a:latin typeface="Century Gothic" charset="0"/>
@@ -7764,7 +7764,7 @@
                 <a:ea typeface="Century Gothic" pitchFamily="34" charset="-122"/>
                 <a:cs typeface="Century Gothic" pitchFamily="34" charset="-120"/>
               </a:rPr>
-              <a:t>Las direcciones respaldan las reglas 3, 4 y 5 para que la empresa las sostenga en la CMCAP.</a:t>
+              <a:t>Las direcciones respaldan las reglas 3, 4 y 5 y no usan la práctica ni el avance de la plataforma en sus áreas, para que la empresa las sostenga en la CMCAP.</a:t>
             </a:r>
             <a:endParaRPr lang="en-US" sz="950" dirty="0"/>
           </a:p>
@@ -8985,7 +8985,7 @@
                 <a:ea typeface="Century Gothic" pitchFamily="34" charset="-122"/>
                 <a:cs typeface="Century Gothic" pitchFamily="34" charset="-120"/>
               </a:rPr>
-              <a:t>Respaldo de las direcciones a las reglas de no uso ante la Comisión Mixta de Capacitación (CMCAP).</a:t>
+              <a:t>Respaldo de las direcciones a las reglas de no uso ante la Comisión Mixta de Capacitación, Adiestramiento y Productividad (CMCAP).</a:t>
             </a:r>
             <a:endParaRPr lang="en-US" sz="1050" dirty="0"/>
           </a:p>
@@ -9406,7 +9406,7 @@
                 <a:ea typeface="Calibri" pitchFamily="34" charset="-122"/>
                 <a:cs typeface="Calibri" pitchFamily="34" charset="-120"/>
               </a:rPr>
-              <a:t>Fuente: marco de diseño de la Academia Digital. Las cifras de accidentabilidad se confirman con Seguridad antes de circular.</a:t>
+              <a:t>Fuente: marco de diseño de la Academia Digital. Cifras de accidentabilidad: se confirman con Seguridad. Referencias STPS (DC-3/SIRCE): verificar con Jurídico Laboral.</a:t>
             </a:r>
             <a:endParaRPr lang="en-US" sz="750" dirty="0"/>
           </a:p>
@@ -9811,7 +9811,7 @@
                 <a:ea typeface="Century Gothic" pitchFamily="34" charset="-122"/>
                 <a:cs typeface="Century Gothic" pitchFamily="34" charset="-120"/>
               </a:rPr>
-              <a:t>La práctica debe ser corta y caber en un turno, sin sacar a la persona de la operación.</a:t>
+              <a:t>La práctica debe ser corta y caber en el turno, en una sala o área fuera de la operación; nunca mientras se opera un equipo.</a:t>
             </a:r>
             <a:endParaRPr lang="en-US" sz="1100" dirty="0"/>
           </a:p>
@@ -9933,7 +9933,7 @@
                 <a:ea typeface="Century Gothic" pitchFamily="34" charset="-122"/>
                 <a:cs typeface="Century Gothic" pitchFamily="34" charset="-120"/>
               </a:rPr>
-              <a:t>ISO 45001 y STPS (DC-3/SIRCE) piden evidencia de competencia, no solo de asistencia.</a:t>
+              <a:t>ISO 45001 y STPS (DC-3/SIRCE) piden evidencia de competencia, no solo de asistencia (verificar con Jurídico / Seguridad).</a:t>
             </a:r>
             <a:endParaRPr lang="en-US" sz="1100" dirty="0"/>
           </a:p>
@@ -12103,7 +12103,7 @@
                 <a:ea typeface="Century Gothic" pitchFamily="34" charset="-122"/>
                 <a:cs typeface="Century Gothic" pitchFamily="34" charset="-120"/>
               </a:rPr>
-              <a:t>Misiones de la Academia Digital (este piloto)</a:t>
+              <a:t>Apoyo con las misiones (este piloto); incluye además el procedimiento aprobado del equipo</a:t>
             </a:r>
             <a:endParaRPr lang="en-US" sz="900" dirty="0"/>
           </a:p>
@@ -12827,7 +12827,7 @@
                 <a:ea typeface="Century Gothic" pitchFamily="34" charset="-122"/>
                 <a:cs typeface="Century Gothic" pitchFamily="34" charset="-120"/>
               </a:rPr>
-              <a:t>No cambia el nivel ILUO de nadie.</a:t>
+              <a:t>No asigna ni cambia el nivel ILUO de nadie, ni es requisito para pasar de nivel.</a:t>
             </a:r>
             <a:endParaRPr lang="en-US" sz="1050" dirty="0"/>
           </a:p>
@@ -12862,8 +12862,8 @@
         </p:nvSpPr>
         <p:spPr>
           <a:xfrm>
-            <a:off x="548640" y="5833872"/>
-            <a:ext cx="11109960" cy="384048"/>
+            <a:off x="548640" y="5779008"/>
+            <a:ext cx="11109960" cy="502920"/>
           </a:xfrm>
           <a:prstGeom prst="rect">
             <a:avLst/>
@@ -12882,8 +12882,8 @@
         </p:nvSpPr>
         <p:spPr>
           <a:xfrm>
-            <a:off x="640080" y="5833872"/>
-            <a:ext cx="10927080" cy="384048"/>
+            <a:off x="640080" y="5779008"/>
+            <a:ext cx="10927080" cy="502920"/>
           </a:xfrm>
           <a:prstGeom prst="rect">
             <a:avLst/>
@@ -12921,7 +12921,7 @@
                 <a:ea typeface="Century Gothic" pitchFamily="34" charset="-122"/>
                 <a:cs typeface="Century Gothic" pitchFamily="34" charset="-120"/>
               </a:rPr>
-              <a:t>La alineación con ILUO es una propuesta; se valida con Seguridad y RH antes de usarla en la matriz de competencias.</a:t>
+              <a:t>La alineación con ILUO es una propuesta; se valida con Seguridad, RH y Relaciones Laborales y, para personal sindicalizado, con la CMCAP antes de usarla en la matriz de competencias. Si la matriz ILUO se usa para escalafón, categorías o bonos, aplica además el CCT.</a:t>
             </a:r>
             <a:endParaRPr lang="en-US" sz="900" dirty="0"/>
           </a:p>
@@ -14224,7 +14224,7 @@
                           <a:ea typeface="Century Gothic" pitchFamily="34" charset="-122"/>
                           <a:cs typeface="Century Gothic" pitchFamily="34" charset="-120"/>
                         </a:rPr>
-                        <a:t>Validado con cambios para personal de confianza; sindicalizados: pendiente CMCAP y Jurídico Laboral</a:t>
+                        <a:t>Validado con cambios para personal de confianza; sindicalizados: pendiente CMCAP, revisión del CCT vigente y Jurídico Laboral</a:t>
                       </a:r>
                       <a:endParaRPr lang="en-US" sz="950" dirty="0">
                         <a:latin typeface="Century Gothic" charset="0"/>

</xml_diff>